<commit_message>
Add demo video link to README and presentation, final submission
</commit_message>
<xml_diff>
--- a/docs/presentation/ZIZ_GlucoTwin_Presentation.pptx
+++ b/docs/presentation/ZIZ_GlucoTwin_Presentation.pptx
@@ -136,6 +136,43 @@
     </p:ext>
   </p:extLst>
 </p:presentation>
+</file>
+
+<file path=ppt/revisionInfo.xml><?xml version="1.0" encoding="utf-8"?>
+<p1510:revInfo xmlns:a="http://schemas.openxmlformats.org/drawingml/2006/main" xmlns:r="http://schemas.openxmlformats.org/officeDocument/2006/relationships" xmlns:p1510="http://schemas.microsoft.com/office/powerpoint/2015/10/main">
+  <p1510:revLst>
+    <p1510:client id="{A89FF378-4AF2-4FB3-8980-3A6B1A1F018F}" v="8" dt="2026-10-20T11:23:31.912"/>
+  </p1510:revLst>
+</p1510:revInfo>
+</file>
+
+<file path=ppt/changesInfos/changesInfo1.xml><?xml version="1.0" encoding="utf-8"?>
+<pc:chgInfo xmlns:a="http://schemas.openxmlformats.org/drawingml/2006/main" xmlns:r="http://schemas.openxmlformats.org/officeDocument/2006/relationships" xmlns:ac="http://schemas.microsoft.com/office/drawing/2013/main/command" xmlns:pc="http://schemas.microsoft.com/office/powerpoint/2013/main/command">
+  <pc:docChgLst>
+    <pc:chgData name="PRITESH KUMAR PANDEY" userId="7fedfae80e020e4e" providerId="LiveId" clId="{BEDC8CA6-A8E5-4EE9-837A-6B8E57EB2F9B}"/>
+    <pc:docChg chg="undo custSel modSld">
+      <pc:chgData name="PRITESH KUMAR PANDEY" userId="7fedfae80e020e4e" providerId="LiveId" clId="{BEDC8CA6-A8E5-4EE9-837A-6B8E57EB2F9B}" dt="2026-10-20T11:17:06.956" v="60"/>
+      <pc:docMkLst>
+        <pc:docMk/>
+      </pc:docMkLst>
+      <pc:sldChg chg="modSp mod">
+        <pc:chgData name="PRITESH KUMAR PANDEY" userId="7fedfae80e020e4e" providerId="LiveId" clId="{BEDC8CA6-A8E5-4EE9-837A-6B8E57EB2F9B}" dt="2026-10-20T11:17:06.956" v="60"/>
+        <pc:sldMkLst>
+          <pc:docMk/>
+          <pc:sldMk cId="0" sldId="274"/>
+        </pc:sldMkLst>
+        <pc:spChg chg="mod">
+          <ac:chgData name="PRITESH KUMAR PANDEY" userId="7fedfae80e020e4e" providerId="LiveId" clId="{BEDC8CA6-A8E5-4EE9-837A-6B8E57EB2F9B}" dt="2026-10-20T11:17:06.956" v="60"/>
+          <ac:spMkLst>
+            <pc:docMk/>
+            <pc:sldMk cId="0" sldId="274"/>
+            <ac:spMk id="13" creationId="{00000000-0000-0000-0000-000000000000}"/>
+          </ac:spMkLst>
+        </pc:spChg>
+      </pc:sldChg>
+    </pc:docChg>
+  </pc:docChgLst>
+</pc:chgInfo>
 </file>
 
 <file path=ppt/charts/chart1.xml><?xml version="1.0" encoding="utf-8"?>
@@ -4036,7 +4073,7 @@
           </a:prstGeom>
           <a:extLst>
             <a:ext uri="{C572A759-6A51-4108-AA02-DFA0A04FC94B}">
-              <ma14:wrappingTextBoxFlag xmlns:ma14="http://schemas.microsoft.com/office/mac/drawingml/2011/main" xmlns="" val="0"/>
+              <ma14:wrappingTextBoxFlag xmlns="" xmlns:ma14="http://schemas.microsoft.com/office/mac/drawingml/2011/main" val="0"/>
             </a:ext>
           </a:extLst>
         </p:spPr>
@@ -4195,7 +4232,7 @@
           </a:prstGeom>
           <a:extLst>
             <a:ext uri="{C572A759-6A51-4108-AA02-DFA0A04FC94B}">
-              <ma14:wrappingTextBoxFlag xmlns:ma14="http://schemas.microsoft.com/office/mac/drawingml/2011/main" xmlns="" val="0"/>
+              <ma14:wrappingTextBoxFlag xmlns="" xmlns:ma14="http://schemas.microsoft.com/office/mac/drawingml/2011/main" val="0"/>
             </a:ext>
           </a:extLst>
         </p:spPr>
@@ -4273,7 +4310,7 @@
           </a:prstGeom>
           <a:extLst>
             <a:ext uri="{C572A759-6A51-4108-AA02-DFA0A04FC94B}">
-              <ma14:wrappingTextBoxFlag xmlns:ma14="http://schemas.microsoft.com/office/mac/drawingml/2011/main" xmlns="" val="0"/>
+              <ma14:wrappingTextBoxFlag xmlns="" xmlns:ma14="http://schemas.microsoft.com/office/mac/drawingml/2011/main" val="0"/>
             </a:ext>
           </a:extLst>
         </p:spPr>
@@ -4960,7 +4997,7 @@
           </a:prstGeom>
           <a:extLst>
             <a:ext uri="{C572A759-6A51-4108-AA02-DFA0A04FC94B}">
-              <ma14:wrappingTextBoxFlag xmlns:ma14="http://schemas.microsoft.com/office/mac/drawingml/2011/main" xmlns="" val="0"/>
+              <ma14:wrappingTextBoxFlag xmlns="" xmlns:ma14="http://schemas.microsoft.com/office/mac/drawingml/2011/main" val="0"/>
             </a:ext>
           </a:extLst>
         </p:spPr>
@@ -7642,7 +7679,7 @@
           </a:prstGeom>
           <a:extLst>
             <a:ext uri="{C572A759-6A51-4108-AA02-DFA0A04FC94B}">
-              <ma14:wrappingTextBoxFlag xmlns:ma14="http://schemas.microsoft.com/office/mac/drawingml/2011/main" xmlns="" val="0"/>
+              <ma14:wrappingTextBoxFlag xmlns="" xmlns:ma14="http://schemas.microsoft.com/office/mac/drawingml/2011/main" val="0"/>
             </a:ext>
           </a:extLst>
         </p:spPr>
@@ -8542,7 +8579,7 @@
           </a:prstGeom>
           <a:extLst>
             <a:ext uri="{C572A759-6A51-4108-AA02-DFA0A04FC94B}">
-              <ma14:wrappingTextBoxFlag xmlns:ma14="http://schemas.microsoft.com/office/mac/drawingml/2011/main" xmlns="" val="0"/>
+              <ma14:wrappingTextBoxFlag xmlns="" xmlns:ma14="http://schemas.microsoft.com/office/mac/drawingml/2011/main" val="0"/>
             </a:ext>
           </a:extLst>
         </p:spPr>
@@ -9001,7 +9038,7 @@
           </a:prstGeom>
           <a:extLst>
             <a:ext uri="{C572A759-6A51-4108-AA02-DFA0A04FC94B}">
-              <ma14:wrappingTextBoxFlag xmlns:ma14="http://schemas.microsoft.com/office/mac/drawingml/2011/main" xmlns="" val="0"/>
+              <ma14:wrappingTextBoxFlag xmlns="" xmlns:ma14="http://schemas.microsoft.com/office/mac/drawingml/2011/main" val="0"/>
             </a:ext>
           </a:extLst>
         </p:spPr>
@@ -9830,7 +9867,7 @@
           </a:prstGeom>
           <a:extLst>
             <a:ext uri="{C572A759-6A51-4108-AA02-DFA0A04FC94B}">
-              <ma14:wrappingTextBoxFlag xmlns:ma14="http://schemas.microsoft.com/office/mac/drawingml/2011/main" xmlns="" val="0"/>
+              <ma14:wrappingTextBoxFlag xmlns="" xmlns:ma14="http://schemas.microsoft.com/office/mac/drawingml/2011/main" val="0"/>
             </a:ext>
           </a:extLst>
         </p:spPr>
@@ -10165,7 +10202,7 @@
           </a:prstGeom>
           <a:extLst>
             <a:ext uri="{C572A759-6A51-4108-AA02-DFA0A04FC94B}">
-              <ma14:wrappingTextBoxFlag xmlns:ma14="http://schemas.microsoft.com/office/mac/drawingml/2011/main" xmlns="" val="0"/>
+              <ma14:wrappingTextBoxFlag xmlns="" xmlns:ma14="http://schemas.microsoft.com/office/mac/drawingml/2011/main" val="0"/>
             </a:ext>
           </a:extLst>
         </p:spPr>
@@ -10500,7 +10537,7 @@
           </a:prstGeom>
           <a:extLst>
             <a:ext uri="{C572A759-6A51-4108-AA02-DFA0A04FC94B}">
-              <ma14:wrappingTextBoxFlag xmlns:ma14="http://schemas.microsoft.com/office/mac/drawingml/2011/main" xmlns="" val="0"/>
+              <ma14:wrappingTextBoxFlag xmlns="" xmlns:ma14="http://schemas.microsoft.com/office/mac/drawingml/2011/main" val="0"/>
             </a:ext>
           </a:extLst>
         </p:spPr>
@@ -12187,7 +12224,7 @@
           </a:prstGeom>
           <a:extLst>
             <a:ext uri="{C572A759-6A51-4108-AA02-DFA0A04FC94B}">
-              <ma14:wrappingTextBoxFlag xmlns:ma14="http://schemas.microsoft.com/office/mac/drawingml/2011/main" xmlns="" val="0"/>
+              <ma14:wrappingTextBoxFlag xmlns="" xmlns:ma14="http://schemas.microsoft.com/office/mac/drawingml/2011/main" val="0"/>
             </a:ext>
           </a:extLst>
         </p:spPr>
@@ -12741,7 +12778,7 @@
           </a:prstGeom>
           <a:extLst>
             <a:ext uri="{C572A759-6A51-4108-AA02-DFA0A04FC94B}">
-              <ma14:wrappingTextBoxFlag xmlns:ma14="http://schemas.microsoft.com/office/mac/drawingml/2011/main" xmlns="" val="0"/>
+              <ma14:wrappingTextBoxFlag xmlns="" xmlns:ma14="http://schemas.microsoft.com/office/mac/drawingml/2011/main" val="0"/>
             </a:ext>
           </a:extLst>
         </p:spPr>
@@ -13253,7 +13290,7 @@
           </a:prstGeom>
           <a:extLst>
             <a:ext uri="{C572A759-6A51-4108-AA02-DFA0A04FC94B}">
-              <ma14:wrappingTextBoxFlag xmlns:ma14="http://schemas.microsoft.com/office/mac/drawingml/2011/main" xmlns="" val="0"/>
+              <ma14:wrappingTextBoxFlag xmlns="" xmlns:ma14="http://schemas.microsoft.com/office/mac/drawingml/2011/main" val="0"/>
             </a:ext>
           </a:extLst>
         </p:spPr>
@@ -13767,19 +13804,12 @@
           <a:bodyPr wrap="square" lIns="0" tIns="0" rIns="0" bIns="0" rtlCol="0" anchor="ctr"/>
           <a:lstStyle/>
           <a:p>
-            <a:pPr marL="0" indent="0" algn="ctr">
-              <a:buNone/>
-            </a:pPr>
+            <a:pPr algn="ctr"/>
             <a:r>
-              <a:rPr lang="en-US" sz="1200" b="1" dirty="0">
-                <a:solidFill>
-                  <a:srgbClr val="92400E"/>
-                </a:solidFill>
-                <a:latin typeface="Calibri" pitchFamily="34" charset="0"/>
-                <a:ea typeface="Calibri" pitchFamily="34" charset="-122"/>
-                <a:cs typeface="Calibri" pitchFamily="34" charset="-120"/>
+              <a:rPr lang="en-US" sz="1200" dirty="0">
+                <a:hlinkClick r:id="rId4"/>
               </a:rPr>
-              <a:t>[VIDEO LINK] placeholder</a:t>
+              <a:t>https://youtu.be/DC1_NouZk5E</a:t>
             </a:r>
             <a:endParaRPr lang="en-US" sz="1200" dirty="0"/>
           </a:p>
@@ -13805,7 +13835,7 @@
           </a:prstGeom>
           <a:extLst>
             <a:ext uri="{C572A759-6A51-4108-AA02-DFA0A04FC94B}">
-              <ma14:wrappingTextBoxFlag xmlns:ma14="http://schemas.microsoft.com/office/mac/drawingml/2011/main" xmlns="" val="0"/>
+              <ma14:wrappingTextBoxFlag xmlns="" xmlns:ma14="http://schemas.microsoft.com/office/mac/drawingml/2011/main" val="0"/>
             </a:ext>
           </a:extLst>
         </p:spPr>
@@ -14398,7 +14428,7 @@
           </a:prstGeom>
           <a:extLst>
             <a:ext uri="{C572A759-6A51-4108-AA02-DFA0A04FC94B}">
-              <ma14:wrappingTextBoxFlag xmlns:ma14="http://schemas.microsoft.com/office/mac/drawingml/2011/main" xmlns="" val="0"/>
+              <ma14:wrappingTextBoxFlag xmlns="" xmlns:ma14="http://schemas.microsoft.com/office/mac/drawingml/2011/main" val="0"/>
             </a:ext>
           </a:extLst>
         </p:spPr>
@@ -16318,7 +16348,7 @@
           </a:prstGeom>
           <a:extLst>
             <a:ext uri="{C572A759-6A51-4108-AA02-DFA0A04FC94B}">
-              <ma14:wrappingTextBoxFlag xmlns:ma14="http://schemas.microsoft.com/office/mac/drawingml/2011/main" xmlns="" val="0"/>
+              <ma14:wrappingTextBoxFlag xmlns="" xmlns:ma14="http://schemas.microsoft.com/office/mac/drawingml/2011/main" val="0"/>
             </a:ext>
           </a:extLst>
         </p:spPr>
@@ -18206,7 +18236,7 @@
           </a:prstGeom>
           <a:extLst>
             <a:ext uri="{C572A759-6A51-4108-AA02-DFA0A04FC94B}">
-              <ma14:wrappingTextBoxFlag xmlns:ma14="http://schemas.microsoft.com/office/mac/drawingml/2011/main" xmlns="" val="0"/>
+              <ma14:wrappingTextBoxFlag xmlns="" xmlns:ma14="http://schemas.microsoft.com/office/mac/drawingml/2011/main" val="0"/>
             </a:ext>
           </a:extLst>
         </p:spPr>
@@ -20327,7 +20357,7 @@
           </a:prstGeom>
           <a:extLst>
             <a:ext uri="{C572A759-6A51-4108-AA02-DFA0A04FC94B}">
-              <ma14:wrappingTextBoxFlag xmlns:ma14="http://schemas.microsoft.com/office/mac/drawingml/2011/main" xmlns="" val="0"/>
+              <ma14:wrappingTextBoxFlag xmlns="" xmlns:ma14="http://schemas.microsoft.com/office/mac/drawingml/2011/main" val="0"/>
             </a:ext>
           </a:extLst>
         </p:spPr>
@@ -20512,7 +20542,7 @@
           </a:prstGeom>
           <a:extLst>
             <a:ext uri="{C572A759-6A51-4108-AA02-DFA0A04FC94B}">
-              <ma14:wrappingTextBoxFlag xmlns:ma14="http://schemas.microsoft.com/office/mac/drawingml/2011/main" xmlns="" val="0"/>
+              <ma14:wrappingTextBoxFlag xmlns="" xmlns:ma14="http://schemas.microsoft.com/office/mac/drawingml/2011/main" val="0"/>
             </a:ext>
           </a:extLst>
         </p:spPr>
@@ -20697,7 +20727,7 @@
           </a:prstGeom>
           <a:extLst>
             <a:ext uri="{C572A759-6A51-4108-AA02-DFA0A04FC94B}">
-              <ma14:wrappingTextBoxFlag xmlns:ma14="http://schemas.microsoft.com/office/mac/drawingml/2011/main" xmlns="" val="0"/>
+              <ma14:wrappingTextBoxFlag xmlns="" xmlns:ma14="http://schemas.microsoft.com/office/mac/drawingml/2011/main" val="0"/>
             </a:ext>
           </a:extLst>
         </p:spPr>
@@ -20882,7 +20912,7 @@
           </a:prstGeom>
           <a:extLst>
             <a:ext uri="{C572A759-6A51-4108-AA02-DFA0A04FC94B}">
-              <ma14:wrappingTextBoxFlag xmlns:ma14="http://schemas.microsoft.com/office/mac/drawingml/2011/main" xmlns="" val="0"/>
+              <ma14:wrappingTextBoxFlag xmlns="" xmlns:ma14="http://schemas.microsoft.com/office/mac/drawingml/2011/main" val="0"/>
             </a:ext>
           </a:extLst>
         </p:spPr>
@@ -21067,7 +21097,7 @@
           </a:prstGeom>
           <a:extLst>
             <a:ext uri="{C572A759-6A51-4108-AA02-DFA0A04FC94B}">
-              <ma14:wrappingTextBoxFlag xmlns:ma14="http://schemas.microsoft.com/office/mac/drawingml/2011/main" xmlns="" val="0"/>
+              <ma14:wrappingTextBoxFlag xmlns="" xmlns:ma14="http://schemas.microsoft.com/office/mac/drawingml/2011/main" val="0"/>
             </a:ext>
           </a:extLst>
         </p:spPr>
@@ -21252,7 +21282,7 @@
           </a:prstGeom>
           <a:extLst>
             <a:ext uri="{C572A759-6A51-4108-AA02-DFA0A04FC94B}">
-              <ma14:wrappingTextBoxFlag xmlns:ma14="http://schemas.microsoft.com/office/mac/drawingml/2011/main" xmlns="" val="0"/>
+              <ma14:wrappingTextBoxFlag xmlns="" xmlns:ma14="http://schemas.microsoft.com/office/mac/drawingml/2011/main" val="0"/>
             </a:ext>
           </a:extLst>
         </p:spPr>
@@ -21961,7 +21991,7 @@
           </a:prstGeom>
           <a:extLst>
             <a:ext uri="{C572A759-6A51-4108-AA02-DFA0A04FC94B}">
-              <ma14:wrappingTextBoxFlag xmlns:ma14="http://schemas.microsoft.com/office/mac/drawingml/2011/main" xmlns="" val="0"/>
+              <ma14:wrappingTextBoxFlag xmlns="" xmlns:ma14="http://schemas.microsoft.com/office/mac/drawingml/2011/main" val="0"/>
             </a:ext>
           </a:extLst>
         </p:spPr>
@@ -23025,7 +23055,7 @@
           </a:prstGeom>
           <a:extLst>
             <a:ext uri="{C572A759-6A51-4108-AA02-DFA0A04FC94B}">
-              <ma14:wrappingTextBoxFlag xmlns:ma14="http://schemas.microsoft.com/office/mac/drawingml/2011/main" xmlns="" val="0"/>
+              <ma14:wrappingTextBoxFlag xmlns="" xmlns:ma14="http://schemas.microsoft.com/office/mac/drawingml/2011/main" val="0"/>
             </a:ext>
           </a:extLst>
         </p:spPr>
@@ -24734,7 +24764,7 @@
           </a:prstGeom>
           <a:extLst>
             <a:ext uri="{C572A759-6A51-4108-AA02-DFA0A04FC94B}">
-              <ma14:wrappingTextBoxFlag xmlns:ma14="http://schemas.microsoft.com/office/mac/drawingml/2011/main" xmlns="" val="0"/>
+              <ma14:wrappingTextBoxFlag xmlns="" xmlns:ma14="http://schemas.microsoft.com/office/mac/drawingml/2011/main" val="0"/>
             </a:ext>
           </a:extLst>
         </p:spPr>
@@ -28412,7 +28442,7 @@
           </a:prstGeom>
           <a:extLst>
             <a:ext uri="{C572A759-6A51-4108-AA02-DFA0A04FC94B}">
-              <ma14:wrappingTextBoxFlag xmlns:ma14="http://schemas.microsoft.com/office/mac/drawingml/2011/main" xmlns="" val="0"/>
+              <ma14:wrappingTextBoxFlag xmlns="" xmlns:ma14="http://schemas.microsoft.com/office/mac/drawingml/2011/main" val="0"/>
             </a:ext>
           </a:extLst>
         </p:spPr>
@@ -29223,7 +29253,7 @@
           </a:prstGeom>
           <a:extLst>
             <a:ext uri="{C572A759-6A51-4108-AA02-DFA0A04FC94B}">
-              <ma14:wrappingTextBoxFlag xmlns:ma14="http://schemas.microsoft.com/office/mac/drawingml/2011/main" xmlns="" val="0"/>
+              <ma14:wrappingTextBoxFlag xmlns="" xmlns:ma14="http://schemas.microsoft.com/office/mac/drawingml/2011/main" val="0"/>
             </a:ext>
           </a:extLst>
         </p:spPr>
@@ -30127,7 +30157,7 @@
           </a:prstGeom>
           <a:extLst>
             <a:ext uri="{C572A759-6A51-4108-AA02-DFA0A04FC94B}">
-              <ma14:wrappingTextBoxFlag xmlns:ma14="http://schemas.microsoft.com/office/mac/drawingml/2011/main" xmlns="" val="0"/>
+              <ma14:wrappingTextBoxFlag xmlns="" xmlns:ma14="http://schemas.microsoft.com/office/mac/drawingml/2011/main" val="0"/>
             </a:ext>
           </a:extLst>
         </p:spPr>
@@ -30440,7 +30470,7 @@
           </a:prstGeom>
           <a:extLst>
             <a:ext uri="{C572A759-6A51-4108-AA02-DFA0A04FC94B}">
-              <ma14:wrappingTextBoxFlag xmlns:ma14="http://schemas.microsoft.com/office/mac/drawingml/2011/main" xmlns="" val="0"/>
+              <ma14:wrappingTextBoxFlag xmlns="" xmlns:ma14="http://schemas.microsoft.com/office/mac/drawingml/2011/main" val="0"/>
             </a:ext>
           </a:extLst>
         </p:spPr>

</xml_diff>